<commit_message>
docs: update presentation suite to 10 slides with current feature set
- Upgraded interactive HTML deck, Markdown speaker notes, PPTX, and PDF to 10 slides
- Added dedicated slides for Savings Vault surplus sweeping and Arabic RTL localization
- Updated metrics: 162/162 passing tests, Growth Cycle branding, Apache 2.0 license, and 22.7MB APK
- Documented v1.0.0 release readiness and future roadmap milestones
</commit_message>
<xml_diff>
--- a/SpendWise_Presentation.pptx
+++ b/SpendWise_Presentation.pptx
@@ -14,6 +14,7 @@
     <p:sldId id="262" r:id="rId13"/>
     <p:sldId id="263" r:id="rId14"/>
     <p:sldId id="264" r:id="rId15"/>
+    <p:sldId id="265" r:id="rId16"/>
   </p:sldIdLst>
   <p:sldSz cx="12191695" cy="6858000" type="screen4x3"/>
   <p:notesSz cx="6858000" cy="9144000"/>
@@ -3155,7 +3156,7 @@
         </p:blipFill>
         <p:spPr>
           <a:xfrm>
-            <a:off x="5394960" y="1188720"/>
+            <a:off x="5394960" y="1051560"/>
             <a:ext cx="1371600" cy="1371600"/>
           </a:xfrm>
           <a:prstGeom prst="rect">
@@ -3171,8 +3172,8 @@
         </p:nvSpPr>
         <p:spPr>
           <a:xfrm>
-            <a:off x="914400" y="2743200"/>
-            <a:ext cx="10362895" cy="914400"/>
+            <a:off x="914400" y="2560320"/>
+            <a:ext cx="10362895" cy="822960"/>
           </a:xfrm>
           <a:prstGeom prst="rect">
             <a:avLst/>
@@ -3186,7 +3187,7 @@
           <a:lstStyle/>
           <a:p>
             <a:pPr algn="ctr">
-              <a:defRPr sz="4600" b="1">
+              <a:defRPr sz="4400" b="1">
                 <a:solidFill>
                   <a:srgbClr val="F8FAFC"/>
                 </a:solidFill>
@@ -3206,8 +3207,8 @@
         </p:nvSpPr>
         <p:spPr>
           <a:xfrm>
-            <a:off x="914400" y="3566160"/>
-            <a:ext cx="10362895" cy="548640"/>
+            <a:off x="914400" y="3383280"/>
+            <a:ext cx="10362895" cy="502920"/>
           </a:xfrm>
           <a:prstGeom prst="rect">
             <a:avLst/>
@@ -3223,12 +3224,12 @@
             <a:pPr algn="ctr">
               <a:defRPr sz="2000" b="1">
                 <a:solidFill>
-                  <a:srgbClr val="22C55E"/>
-                </a:solidFill>
-              </a:defRPr>
-            </a:pPr>
-            <a:r>
-              <a:t>Smart, Simple &amp; Offline-First Personal Finance</a:t>
+                  <a:srgbClr val="16A34A"/>
+                </a:solidFill>
+              </a:defRPr>
+            </a:pPr>
+            <a:r>
+              <a:t>Private, Payday-Aligned Personal Finance</a:t>
             </a:r>
           </a:p>
         </p:txBody>
@@ -3241,7 +3242,7 @@
         </p:nvSpPr>
         <p:spPr>
           <a:xfrm>
-            <a:off x="1828800" y="4114800"/>
+            <a:off x="1828800" y="3977639"/>
             <a:ext cx="8534095" cy="548640"/>
           </a:xfrm>
           <a:prstGeom prst="rect">
@@ -3276,8 +3277,8 @@
         </p:nvSpPr>
         <p:spPr>
           <a:xfrm>
-            <a:off x="731520" y="5029200"/>
-            <a:ext cx="2423160" cy="1097280"/>
+            <a:off x="731520" y="4892040"/>
+            <a:ext cx="2423160" cy="1234440"/>
           </a:xfrm>
           <a:prstGeom prst="roundRect">
             <a:avLst/>
@@ -3312,7 +3313,7 @@
             <a:pPr algn="ctr">
               <a:defRPr sz="1500" b="1">
                 <a:solidFill>
-                  <a:srgbClr val="22C55E"/>
+                  <a:srgbClr val="16A34A"/>
                 </a:solidFill>
               </a:defRPr>
             </a:pPr>
@@ -3329,7 +3330,7 @@
               </a:defRPr>
             </a:pPr>
             <a:r>
-              <a:t>Local SQLite database</a:t>
+              <a:t>Local SQLite &amp; Zero Tracking</a:t>
             </a:r>
           </a:p>
         </p:txBody>
@@ -3342,8 +3343,8 @@
         </p:nvSpPr>
         <p:spPr>
           <a:xfrm>
-            <a:off x="3502152" y="5029200"/>
-            <a:ext cx="2423160" cy="1097280"/>
+            <a:off x="3502152" y="4892040"/>
+            <a:ext cx="2423160" cy="1234440"/>
           </a:xfrm>
           <a:prstGeom prst="roundRect">
             <a:avLst/>
@@ -3395,7 +3396,7 @@
               </a:defRPr>
             </a:pPr>
             <a:r>
-              <a:t>Matches real paydays</a:t>
+              <a:t>Matches Real-Life Paydays</a:t>
             </a:r>
           </a:p>
         </p:txBody>
@@ -3408,8 +3409,8 @@
         </p:nvSpPr>
         <p:spPr>
           <a:xfrm>
-            <a:off x="6272784" y="5029200"/>
-            <a:ext cx="2423160" cy="1097280"/>
+            <a:off x="6272784" y="4892040"/>
+            <a:ext cx="2423160" cy="1234440"/>
           </a:xfrm>
           <a:prstGeom prst="roundRect">
             <a:avLst/>
@@ -3449,7 +3450,7 @@
               </a:defRPr>
             </a:pPr>
             <a:r>
-              <a:t>&lt; 1s Entry</a:t>
+              <a:t>&lt; 1s 1-Tap Entry</a:t>
             </a:r>
           </a:p>
           <a:p>
@@ -3461,7 +3462,7 @@
               </a:defRPr>
             </a:pPr>
             <a:r>
-              <a:t>1-Tap Quick Presets</a:t>
+              <a:t>Instant Presets &amp; Soft Undo</a:t>
             </a:r>
           </a:p>
         </p:txBody>
@@ -3474,8 +3475,8 @@
         </p:nvSpPr>
         <p:spPr>
           <a:xfrm>
-            <a:off x="9043416" y="5029200"/>
-            <a:ext cx="2423160" cy="1097280"/>
+            <a:off x="9043416" y="4892040"/>
+            <a:ext cx="2423160" cy="1234440"/>
           </a:xfrm>
           <a:prstGeom prst="roundRect">
             <a:avLst/>
@@ -3510,12 +3511,12 @@
             <a:pPr algn="ctr">
               <a:defRPr sz="1500" b="1">
                 <a:solidFill>
-                  <a:srgbClr val="22C55E"/>
-                </a:solidFill>
-              </a:defRPr>
-            </a:pPr>
-            <a:r>
-              <a:t>90 / 90 Tests</a:t>
+                  <a:srgbClr val="16A34A"/>
+                </a:solidFill>
+              </a:defRPr>
+            </a:pPr>
+            <a:r>
+              <a:t>162 / 162 Tests</a:t>
             </a:r>
           </a:p>
           <a:p>
@@ -3527,7 +3528,393 @@
               </a:defRPr>
             </a:pPr>
             <a:r>
-              <a:t>100% passing test suite</a:t>
+              <a:t>100% Passing &amp; Apache 2.0</a:t>
+            </a:r>
+          </a:p>
+        </p:txBody>
+      </p:sp>
+    </p:spTree>
+  </p:cSld>
+  <p:clrMapOvr>
+    <a:masterClrMapping/>
+  </p:clrMapOvr>
+</p:sld>
+</file>
+
+<file path=ppt/slides/slide10.xml><?xml version="1.0" encoding="utf-8"?>
+<p:sld xmlns:a="http://schemas.openxmlformats.org/drawingml/2006/main" xmlns:p="http://schemas.openxmlformats.org/presentationml/2006/main" xmlns:r="http://schemas.openxmlformats.org/officeDocument/2006/relationships">
+  <p:cSld>
+    <p:spTree>
+      <p:nvGrpSpPr>
+        <p:cNvPr id="1" name=""/>
+        <p:cNvGrpSpPr/>
+        <p:nvPr/>
+      </p:nvGrpSpPr>
+      <p:grpSpPr/>
+      <p:sp>
+        <p:nvSpPr>
+          <p:cNvPr id="2" name="Rectangle 1"/>
+          <p:cNvSpPr/>
+          <p:nvPr/>
+        </p:nvSpPr>
+        <p:spPr>
+          <a:xfrm>
+            <a:off x="0" y="0"/>
+            <a:ext cx="12191695" cy="6858000"/>
+          </a:xfrm>
+          <a:prstGeom prst="rect">
+            <a:avLst/>
+          </a:prstGeom>
+          <a:solidFill>
+            <a:srgbClr val="0F172A"/>
+          </a:solidFill>
+          <a:ln>
+            <a:noFill/>
+          </a:ln>
+        </p:spPr>
+        <p:style>
+          <a:lnRef idx="1">
+            <a:schemeClr val="accent1"/>
+          </a:lnRef>
+          <a:fillRef idx="3">
+            <a:schemeClr val="accent1"/>
+          </a:fillRef>
+          <a:effectRef idx="2">
+            <a:schemeClr val="accent1"/>
+          </a:effectRef>
+          <a:fontRef idx="minor">
+            <a:schemeClr val="lt1"/>
+          </a:fontRef>
+        </p:style>
+        <p:txBody>
+          <a:bodyPr rtlCol="0" anchor="ctr"/>
+          <a:lstStyle/>
+          <a:p>
+            <a:pPr algn="ctr"/>
+          </a:p>
+        </p:txBody>
+      </p:sp>
+      <p:sp>
+        <p:nvSpPr>
+          <p:cNvPr id="3" name="Rectangle 2"/>
+          <p:cNvSpPr/>
+          <p:nvPr/>
+        </p:nvSpPr>
+        <p:spPr>
+          <a:xfrm>
+            <a:off x="731520" y="365760"/>
+            <a:ext cx="10728655" cy="18288"/>
+          </a:xfrm>
+          <a:prstGeom prst="rect">
+            <a:avLst/>
+          </a:prstGeom>
+          <a:solidFill>
+            <a:srgbClr val="334155"/>
+          </a:solidFill>
+          <a:ln>
+            <a:noFill/>
+          </a:ln>
+        </p:spPr>
+        <p:style>
+          <a:lnRef idx="1">
+            <a:schemeClr val="accent1"/>
+          </a:lnRef>
+          <a:fillRef idx="3">
+            <a:schemeClr val="accent1"/>
+          </a:fillRef>
+          <a:effectRef idx="2">
+            <a:schemeClr val="accent1"/>
+          </a:effectRef>
+          <a:fontRef idx="minor">
+            <a:schemeClr val="lt1"/>
+          </a:fontRef>
+        </p:style>
+        <p:txBody>
+          <a:bodyPr rtlCol="0" anchor="ctr"/>
+          <a:lstStyle/>
+          <a:p>
+            <a:pPr algn="ctr"/>
+          </a:p>
+        </p:txBody>
+      </p:sp>
+      <p:sp>
+        <p:nvSpPr>
+          <p:cNvPr id="4" name="TextBox 3"/>
+          <p:cNvSpPr txBox="1"/>
+          <p:nvPr/>
+        </p:nvSpPr>
+        <p:spPr>
+          <a:xfrm>
+            <a:off x="731520" y="502920"/>
+            <a:ext cx="10728655" cy="320040"/>
+          </a:xfrm>
+          <a:prstGeom prst="rect">
+            <a:avLst/>
+          </a:prstGeom>
+          <a:noFill/>
+        </p:spPr>
+        <p:txBody>
+          <a:bodyPr wrap="square">
+            <a:spAutoFit/>
+          </a:bodyPr>
+          <a:lstStyle/>
+          <a:p>
+            <a:pPr>
+              <a:defRPr sz="1000" b="1">
+                <a:solidFill>
+                  <a:srgbClr val="16A34A"/>
+                </a:solidFill>
+              </a:defRPr>
+            </a:pPr>
+            <a:r>
+              <a:t>OPEN SOURCE &amp; ROADMAP</a:t>
+            </a:r>
+          </a:p>
+        </p:txBody>
+      </p:sp>
+      <p:sp>
+        <p:nvSpPr>
+          <p:cNvPr id="5" name="TextBox 4"/>
+          <p:cNvSpPr txBox="1"/>
+          <p:nvPr/>
+        </p:nvSpPr>
+        <p:spPr>
+          <a:xfrm>
+            <a:off x="731520" y="777240"/>
+            <a:ext cx="10728655" cy="548640"/>
+          </a:xfrm>
+          <a:prstGeom prst="rect">
+            <a:avLst/>
+          </a:prstGeom>
+          <a:noFill/>
+        </p:spPr>
+        <p:txBody>
+          <a:bodyPr wrap="square">
+            <a:spAutoFit/>
+          </a:bodyPr>
+          <a:lstStyle/>
+          <a:p>
+            <a:pPr>
+              <a:defRPr sz="2400" b="1">
+                <a:solidFill>
+                  <a:srgbClr val="F8FAFC"/>
+                </a:solidFill>
+              </a:defRPr>
+            </a:pPr>
+            <a:r>
+              <a:t>SpendWise: v1.0.0 Ready &amp; Future Horizons</a:t>
+            </a:r>
+          </a:p>
+        </p:txBody>
+      </p:sp>
+      <p:sp>
+        <p:nvSpPr>
+          <p:cNvPr id="6" name="TextBox 5"/>
+          <p:cNvSpPr txBox="1"/>
+          <p:nvPr/>
+        </p:nvSpPr>
+        <p:spPr>
+          <a:xfrm>
+            <a:off x="731520" y="1280160"/>
+            <a:ext cx="10728655" cy="365760"/>
+          </a:xfrm>
+          <a:prstGeom prst="rect">
+            <a:avLst/>
+          </a:prstGeom>
+          <a:noFill/>
+        </p:spPr>
+        <p:txBody>
+          <a:bodyPr wrap="square">
+            <a:spAutoFit/>
+          </a:bodyPr>
+          <a:lstStyle/>
+          <a:p>
+            <a:pPr>
+              <a:defRPr sz="1200">
+                <a:solidFill>
+                  <a:srgbClr val="94A3B8"/>
+                </a:solidFill>
+              </a:defRPr>
+            </a:pPr>
+            <a:r>
+              <a:t>Empowering users with effortless financial clarity every single day.</a:t>
+            </a:r>
+          </a:p>
+        </p:txBody>
+      </p:sp>
+      <p:sp>
+        <p:nvSpPr>
+          <p:cNvPr id="7" name="Rounded Rectangle 6"/>
+          <p:cNvSpPr/>
+          <p:nvPr/>
+        </p:nvSpPr>
+        <p:spPr>
+          <a:xfrm>
+            <a:off x="731520" y="2011680"/>
+            <a:ext cx="5120640" cy="3931920"/>
+          </a:xfrm>
+          <a:prstGeom prst="roundRect">
+            <a:avLst/>
+          </a:prstGeom>
+          <a:solidFill>
+            <a:srgbClr val="1E293B"/>
+          </a:solidFill>
+          <a:ln w="19050">
+            <a:solidFill>
+              <a:srgbClr val="16A34A"/>
+            </a:solidFill>
+          </a:ln>
+        </p:spPr>
+        <p:style>
+          <a:lnRef idx="1">
+            <a:schemeClr val="accent1"/>
+          </a:lnRef>
+          <a:fillRef idx="3">
+            <a:schemeClr val="accent1"/>
+          </a:fillRef>
+          <a:effectRef idx="2">
+            <a:schemeClr val="accent1"/>
+          </a:effectRef>
+          <a:fontRef idx="minor">
+            <a:schemeClr val="lt1"/>
+          </a:fontRef>
+        </p:style>
+        <p:txBody>
+          <a:bodyPr rtlCol="0" anchor="ctr" wrap="square" tIns="274320" lIns="274320" rIns="274320"/>
+          <a:lstStyle/>
+          <a:p>
+            <a:pPr algn="ctr">
+              <a:defRPr sz="1200" b="1">
+                <a:solidFill>
+                  <a:srgbClr val="16A34A"/>
+                </a:solidFill>
+              </a:defRPr>
+            </a:pPr>
+            <a:r>
+              <a:t>WHAT SETS SPENDWISE APART</a:t>
+            </a:r>
+          </a:p>
+          <a:p>
+            <a:pPr>
+              <a:defRPr sz="1100">
+                <a:solidFill>
+                  <a:srgbClr val="F8FAFC"/>
+                </a:solidFill>
+              </a:defRPr>
+            </a:pPr>
+            <a:r>
+              <a:t>• Built for real paydays: 25th-to-24th salary cycle.</a:t>
+            </a:r>
+            <a:br/>
+            <a:r>
+              <a:t>• Sub-second entry: 1-Tap quick presets with Undo.</a:t>
+            </a:r>
+            <a:br/>
+            <a:r>
+              <a:t>• Automated savings: Surplus sweeper &amp; multi-goal vault.</a:t>
+            </a:r>
+            <a:br/>
+            <a:r>
+              <a:t>• Native Arabic RTL: Full mirroring &amp; Eastern numerals.</a:t>
+            </a:r>
+            <a:br/>
+            <a:r>
+              <a:t>• 100% privacy: Zero tracking, local SQLite storage.</a:t>
+            </a:r>
+            <a:br/>
+            <a:r>
+              <a:t>• Production-ready: 162 automated tests, 22.7 MB APK.</a:t>
+            </a:r>
+          </a:p>
+        </p:txBody>
+      </p:sp>
+      <p:sp>
+        <p:nvSpPr>
+          <p:cNvPr id="8" name="Rounded Rectangle 7"/>
+          <p:cNvSpPr/>
+          <p:nvPr/>
+        </p:nvSpPr>
+        <p:spPr>
+          <a:xfrm>
+            <a:off x="6217920" y="2011680"/>
+            <a:ext cx="5212080" cy="3931920"/>
+          </a:xfrm>
+          <a:prstGeom prst="roundRect">
+            <a:avLst/>
+          </a:prstGeom>
+          <a:solidFill>
+            <a:srgbClr val="1E293B"/>
+          </a:solidFill>
+          <a:ln w="19050">
+            <a:solidFill>
+              <a:srgbClr val="6366F1"/>
+            </a:solidFill>
+          </a:ln>
+        </p:spPr>
+        <p:style>
+          <a:lnRef idx="1">
+            <a:schemeClr val="accent1"/>
+          </a:lnRef>
+          <a:fillRef idx="3">
+            <a:schemeClr val="accent1"/>
+          </a:fillRef>
+          <a:effectRef idx="2">
+            <a:schemeClr val="accent1"/>
+          </a:effectRef>
+          <a:fontRef idx="minor">
+            <a:schemeClr val="lt1"/>
+          </a:fontRef>
+        </p:style>
+        <p:txBody>
+          <a:bodyPr rtlCol="0" anchor="ctr" wrap="square" tIns="274320" lIns="274320" rIns="274320"/>
+          <a:lstStyle/>
+          <a:p>
+            <a:pPr algn="ctr">
+              <a:defRPr sz="1200" b="1">
+                <a:solidFill>
+                  <a:srgbClr val="6366F1"/>
+                </a:solidFill>
+              </a:defRPr>
+            </a:pPr>
+            <a:r>
+              <a:t>OPEN SOURCE &amp; UPCOMING HORIZONS</a:t>
+            </a:r>
+          </a:p>
+          <a:p>
+            <a:pPr>
+              <a:defRPr sz="1100">
+                <a:solidFill>
+                  <a:srgbClr val="F8FAFC"/>
+                </a:solidFill>
+              </a:defRPr>
+            </a:pPr>
+            <a:r>
+              <a:t>• Open Source: Apache License 2.0</a:t>
+            </a:r>
+            <a:br/>
+            <a:r>
+              <a:t>  GitHub: https://github.com/hosamsemry/SpendWise</a:t>
+            </a:r>
+            <a:br/>
+            <a:br/>
+            <a:r>
+              <a:t>• Upcoming v1.1 Horizon:</a:t>
+            </a:r>
+            <a:br/>
+            <a:r>
+              <a:t>  - Multi-Currency Conversion with cached offline exchange rates</a:t>
+            </a:r>
+            <a:br/>
+            <a:r>
+              <a:t>  - Camera Receipt OCR for automatic expense drafting</a:t>
+            </a:r>
+            <a:br/>
+            <a:r>
+              <a:t>  - Interactive Category Donut Chart in Reports</a:t>
+            </a:r>
+            <a:br/>
+            <a:r>
+              <a:t>  - Recurring Subscriptions &amp; Utility Bills Calendar</a:t>
             </a:r>
           </a:p>
         </p:txBody>
@@ -3661,7 +4048,7 @@
             <a:pPr>
               <a:defRPr sz="1000" b="1">
                 <a:solidFill>
-                  <a:srgbClr val="22C55E"/>
+                  <a:srgbClr val="16A34A"/>
                 </a:solidFill>
               </a:defRPr>
             </a:pPr>
@@ -3750,6 +4137,77 @@
         <p:spPr>
           <a:xfrm>
             <a:off x="731520" y="2011680"/>
+            <a:ext cx="3328416" cy="4114800"/>
+          </a:xfrm>
+          <a:prstGeom prst="roundRect">
+            <a:avLst/>
+          </a:prstGeom>
+          <a:solidFill>
+            <a:srgbClr val="1E293B"/>
+          </a:solidFill>
+          <a:ln w="19050">
+            <a:solidFill>
+              <a:srgbClr val="F59E0B"/>
+            </a:solidFill>
+          </a:ln>
+        </p:spPr>
+        <p:style>
+          <a:lnRef idx="1">
+            <a:schemeClr val="accent1"/>
+          </a:lnRef>
+          <a:fillRef idx="3">
+            <a:schemeClr val="accent1"/>
+          </a:fillRef>
+          <a:effectRef idx="2">
+            <a:schemeClr val="accent1"/>
+          </a:effectRef>
+          <a:fontRef idx="minor">
+            <a:schemeClr val="lt1"/>
+          </a:fontRef>
+        </p:style>
+        <p:txBody>
+          <a:bodyPr rtlCol="0" anchor="ctr" wrap="square" tIns="274320" lIns="274320" rIns="274320"/>
+          <a:lstStyle/>
+          <a:p>
+            <a:pPr algn="ctr">
+              <a:defRPr sz="1600" b="1">
+                <a:solidFill>
+                  <a:srgbClr val="F59E0B"/>
+                </a:solidFill>
+              </a:defRPr>
+            </a:pPr>
+            <a:r>
+              <a:t>1. The '1st of the Month' Fallacy</a:t>
+            </a:r>
+          </a:p>
+          <a:p>
+            <a:pPr>
+              <a:defRPr sz="1200">
+                <a:solidFill>
+                  <a:srgbClr val="F8FAFC"/>
+                </a:solidFill>
+              </a:defRPr>
+            </a:pPr>
+            <a:r>
+              <a:t>Traditional apps tie budgets strictly to calendar months (1st to 30th).</a:t>
+            </a:r>
+            <a:br/>
+            <a:br/>
+            <a:r>
+              <a:t>In reality, professionals receive salaries on the 25th, resulting in artificial deficits, skewed metrics, and month-end confusion.</a:t>
+            </a:r>
+          </a:p>
+        </p:txBody>
+      </p:sp>
+      <p:sp>
+        <p:nvSpPr>
+          <p:cNvPr id="8" name="Rounded Rectangle 7"/>
+          <p:cNvSpPr/>
+          <p:nvPr/>
+        </p:nvSpPr>
+        <p:spPr>
+          <a:xfrm>
+            <a:off x="4425696" y="2011680"/>
             <a:ext cx="3328416" cy="4114800"/>
           </a:xfrm>
           <a:prstGeom prst="roundRect">
@@ -3790,7 +4248,7 @@
               </a:defRPr>
             </a:pPr>
             <a:r>
-              <a:t>1. High Entry Friction</a:t>
+              <a:t>2. High Entry Friction</a:t>
             </a:r>
           </a:p>
           <a:p>
@@ -3802,83 +4260,12 @@
               </a:defRPr>
             </a:pPr>
             <a:r>
-              <a:t>Logging a cup of coffee takes 4 to 5 screens, date pickers, notes, and confirmations.</a:t>
-            </a:r>
-            <a:br/>
-            <a:br/>
-            <a:r>
-              <a:t>When entry takes more than 3 seconds, users quit logging daily expenses.</a:t>
-            </a:r>
-          </a:p>
-        </p:txBody>
-      </p:sp>
-      <p:sp>
-        <p:nvSpPr>
-          <p:cNvPr id="8" name="Rounded Rectangle 7"/>
-          <p:cNvSpPr/>
-          <p:nvPr/>
-        </p:nvSpPr>
-        <p:spPr>
-          <a:xfrm>
-            <a:off x="4425696" y="2011680"/>
-            <a:ext cx="3328416" cy="4114800"/>
-          </a:xfrm>
-          <a:prstGeom prst="roundRect">
-            <a:avLst/>
-          </a:prstGeom>
-          <a:solidFill>
-            <a:srgbClr val="1E293B"/>
-          </a:solidFill>
-          <a:ln w="19050">
-            <a:solidFill>
-              <a:srgbClr val="F59E0B"/>
-            </a:solidFill>
-          </a:ln>
-        </p:spPr>
-        <p:style>
-          <a:lnRef idx="1">
-            <a:schemeClr val="accent1"/>
-          </a:lnRef>
-          <a:fillRef idx="3">
-            <a:schemeClr val="accent1"/>
-          </a:fillRef>
-          <a:effectRef idx="2">
-            <a:schemeClr val="accent1"/>
-          </a:effectRef>
-          <a:fontRef idx="minor">
-            <a:schemeClr val="lt1"/>
-          </a:fontRef>
-        </p:style>
-        <p:txBody>
-          <a:bodyPr rtlCol="0" anchor="ctr" wrap="square" tIns="274320" lIns="274320" rIns="274320"/>
-          <a:lstStyle/>
-          <a:p>
-            <a:pPr algn="ctr">
-              <a:defRPr sz="1600" b="1">
-                <a:solidFill>
-                  <a:srgbClr val="F59E0B"/>
-                </a:solidFill>
-              </a:defRPr>
-            </a:pPr>
-            <a:r>
-              <a:t>2. The '1st of the Month' Fallacy</a:t>
-            </a:r>
-          </a:p>
-          <a:p>
-            <a:pPr>
-              <a:defRPr sz="1200">
-                <a:solidFill>
-                  <a:srgbClr val="F8FAFC"/>
-                </a:solidFill>
-              </a:defRPr>
-            </a:pPr>
-            <a:r>
-              <a:t>Traditional apps tie budgets to calendar months (1st to 30th).</a:t>
-            </a:r>
-            <a:br/>
-            <a:br/>
-            <a:r>
-              <a:t>In reality, professionals receive salaries on the 25th, making standard calendar reports useless for cash flow.</a:t>
+              <a:t>Logging a single cup of coffee takes 4 to 5 screens, category dropdowns, date pickers, and confirmations.</a:t>
+            </a:r>
+            <a:br/>
+            <a:br/>
+            <a:r>
+              <a:t>When entry takes more than 3 seconds, users quit tracking within days.</a:t>
             </a:r>
           </a:p>
         </p:txBody>
@@ -3932,7 +4319,7 @@
               </a:defRPr>
             </a:pPr>
             <a:r>
-              <a:t>3. Cloud Bloat &amp; Privacy Risks</a:t>
+              <a:t>3. Cloud Bloat &amp; Privacy Liabilities</a:t>
             </a:r>
           </a:p>
           <a:p>
@@ -3944,12 +4331,12 @@
               </a:defRPr>
             </a:pPr>
             <a:r>
-              <a:t>Forced account registrations, third-party analytics, and bank syncing dependencies.</a:t>
-            </a:r>
-            <a:br/>
-            <a:br/>
-            <a:r>
-              <a:t>Apps often exceed 200MB, drain battery, and store personal financial records on external servers.</a:t>
+              <a:t>Forced account signups, mandatory bank linking, third-party analytics, and advertising SDKs.</a:t>
+            </a:r>
+            <a:br/>
+            <a:br/>
+            <a:r>
+              <a:t>Apps exceed 150MB, leak financial data to cloud servers, and fail offline.</a:t>
             </a:r>
           </a:p>
         </p:txBody>
@@ -4083,7 +4470,7 @@
             <a:pPr>
               <a:defRPr sz="1000" b="1">
                 <a:solidFill>
-                  <a:srgbClr val="22C55E"/>
+                  <a:srgbClr val="16A34A"/>
                 </a:solidFill>
               </a:defRPr>
             </a:pPr>
@@ -4277,7 +4664,7 @@
             <a:pPr algn="ctr">
               <a:defRPr sz="1500" b="1">
                 <a:solidFill>
-                  <a:srgbClr val="22C55E"/>
+                  <a:srgbClr val="16A34A"/>
                 </a:solidFill>
               </a:defRPr>
             </a:pPr>
@@ -4352,7 +4739,7 @@
               </a:defRPr>
             </a:pPr>
             <a:r>
-              <a:t>Segregated Categories</a:t>
+              <a:t>Strict Category Segregation</a:t>
             </a:r>
           </a:p>
           <a:p>
@@ -4417,7 +4804,7 @@
             <a:pPr algn="ctr">
               <a:defRPr sz="1500" b="1">
                 <a:solidFill>
-                  <a:srgbClr val="22C55E"/>
+                  <a:srgbClr val="16A34A"/>
                 </a:solidFill>
               </a:defRPr>
             </a:pPr>
@@ -4434,7 +4821,7 @@
               </a:defRPr>
             </a:pPr>
             <a:r>
-              <a:t>Optimized APK bundle size under 80MB.</a:t>
+              <a:t>Optimized APK: 22.7 MB ARM64 / 62.1 MB Universal.</a:t>
             </a:r>
             <a:br/>
             <a:r>
@@ -4572,7 +4959,7 @@
             <a:pPr>
               <a:defRPr sz="1000" b="1">
                 <a:solidFill>
-                  <a:srgbClr val="22C55E"/>
+                  <a:srgbClr val="16A34A"/>
                 </a:solidFill>
               </a:defRPr>
             </a:pPr>
@@ -4612,7 +4999,7 @@
               </a:defRPr>
             </a:pPr>
             <a:r>
-              <a:t>1-Tap Direct Quick Presets</a:t>
+              <a:t>1-Tap Direct Quick Presets &amp; Soft Undo</a:t>
             </a:r>
           </a:p>
         </p:txBody>
@@ -4713,7 +5100,7 @@
               </a:defRPr>
             </a:pPr>
             <a:r>
-              <a:t>Tapping a preset chip (e.g. 'Espresso • 45.00 EGP') immediately writes to SQLite without opening dialogs.</a:t>
+              <a:t>Tapping a preset chip (e.g. 'Espresso • 45.00 EGP') immediately writes to SQLite without opening forms or dialogs.</a:t>
             </a:r>
           </a:p>
         </p:txBody>
@@ -4833,7 +5220,7 @@
               </a:defRPr>
             </a:pPr>
             <a:r>
-              <a:t>Dynamic Budget Monitoring</a:t>
+              <a:t>Dynamic Budget Monitoring &amp; Haptics</a:t>
             </a:r>
           </a:p>
           <a:p>
@@ -4845,7 +5232,7 @@
               </a:defRPr>
             </a:pPr>
             <a:r>
-              <a:t>Even with 1-tap logging, budget limits are immediately calculated. Alerts trigger if approaching category thresholds.</a:t>
+              <a:t>Budget limits update instantly upon logging. Gentle tactile vibration provides reassuring physical feedback.</a:t>
             </a:r>
           </a:p>
         </p:txBody>
@@ -4935,7 +5322,7 @@
             <a:pPr>
               <a:defRPr sz="1100">
                 <a:solidFill>
-                  <a:srgbClr val="22C55E"/>
+                  <a:srgbClr val="16A34A"/>
                 </a:solidFill>
               </a:defRPr>
             </a:pPr>
@@ -5082,7 +5469,7 @@
             <a:pPr>
               <a:defRPr sz="1000" b="1">
                 <a:solidFill>
-                  <a:srgbClr val="22C55E"/>
+                  <a:srgbClr val="16A34A"/>
                 </a:solidFill>
               </a:defRPr>
             </a:pPr>
@@ -5122,7 +5509,7 @@
               </a:defRPr>
             </a:pPr>
             <a:r>
-              <a:t>Daily Spending Sum &amp; Dynamic Safe Pace</a:t>
+              <a:t>Daily Spending Clarity &amp; Dynamic Safe Pace</a:t>
             </a:r>
           </a:p>
         </p:txBody>
@@ -5181,7 +5568,7 @@
           </a:solidFill>
           <a:ln w="19050">
             <a:solidFill>
-              <a:srgbClr val="22C55E"/>
+              <a:srgbClr val="16A34A"/>
             </a:solidFill>
           </a:ln>
         </p:spPr>
@@ -5206,7 +5593,7 @@
             <a:pPr algn="ctr">
               <a:defRPr sz="1200" b="1">
                 <a:solidFill>
-                  <a:srgbClr val="22C55E"/>
+                  <a:srgbClr val="16A34A"/>
                 </a:solidFill>
               </a:defRPr>
             </a:pPr>
@@ -5488,12 +5875,12 @@
             <a:pPr>
               <a:defRPr sz="1000" b="1">
                 <a:solidFill>
-                  <a:srgbClr val="22C55E"/>
-                </a:solidFill>
-              </a:defRPr>
-            </a:pPr>
-            <a:r>
-              <a:t>REPORTING &amp; ANALYTICS</a:t>
+                  <a:srgbClr val="16A34A"/>
+                </a:solidFill>
+              </a:defRPr>
+            </a:pPr>
+            <a:r>
+              <a:t>AUTOMATED WEALTH DISCIPLINE</a:t>
             </a:r>
           </a:p>
         </p:txBody>
@@ -5528,7 +5915,7 @@
               </a:defRPr>
             </a:pPr>
             <a:r>
-              <a:t>Visual Reports &amp; Cash Flow Trends</a:t>
+              <a:t>Savings Vault &amp; Surplus Sweeper</a:t>
             </a:r>
           </a:p>
         </p:txBody>
@@ -5563,7 +5950,7 @@
               </a:defRPr>
             </a:pPr>
             <a:r>
-              <a:t>Comprehensive budget analysis without complicated accounting spreadsheets.</a:t>
+              <a:t>Turn month-end leftovers into long-term wealth without manual transfers.</a:t>
             </a:r>
           </a:p>
         </p:txBody>
@@ -5577,7 +5964,7 @@
         <p:spPr>
           <a:xfrm>
             <a:off x="731520" y="2011680"/>
-            <a:ext cx="3328416" cy="4114800"/>
+            <a:ext cx="5120640" cy="3931920"/>
           </a:xfrm>
           <a:prstGeom prst="roundRect">
             <a:avLst/>
@@ -5587,7 +5974,7 @@
           </a:solidFill>
           <a:ln w="19050">
             <a:solidFill>
-              <a:srgbClr val="6366F1"/>
+              <a:srgbClr val="16A34A"/>
             </a:solidFill>
           </a:ln>
         </p:spPr>
@@ -5610,31 +5997,60 @@
           <a:lstStyle/>
           <a:p>
             <a:pPr algn="ctr">
-              <a:defRPr sz="1600" b="1">
-                <a:solidFill>
-                  <a:srgbClr val="6366F1"/>
-                </a:solidFill>
-              </a:defRPr>
-            </a:pPr>
-            <a:r>
-              <a:t>Category Spending</a:t>
+              <a:defRPr sz="1200" b="1">
+                <a:solidFill>
+                  <a:srgbClr val="16A34A"/>
+                </a:solidFill>
+              </a:defRPr>
+            </a:pPr>
+            <a:r>
+              <a:t>AUTOMATIC CLOSEOUT SWEEPER</a:t>
             </a:r>
           </a:p>
           <a:p>
             <a:pPr>
-              <a:defRPr sz="1200">
+              <a:defRPr sz="1100">
                 <a:solidFill>
                   <a:srgbClr val="F8FAFC"/>
                 </a:solidFill>
               </a:defRPr>
             </a:pPr>
             <a:r>
-              <a:t>Ranked expense breakdown with percentage share progress bars.</a:t>
-            </a:r>
-            <a:br/>
-            <a:br/>
-            <a:r>
-              <a:t>Quickly identify where the largest share of your budget went during the current 25th-to-24th cycle.</a:t>
+              <a:t>• Salary Rollover Closeout:</a:t>
+            </a:r>
+            <a:br/>
+            <a:r>
+              <a:t>  When a new 25th arrives, unspent operational budget isn't lost or reset — it is swept into your Savings Vault.</a:t>
+            </a:r>
+            <a:br/>
+            <a:br/>
+            <a:r>
+              <a:t>• Rollover Preview Dialog:</a:t>
+            </a:r>
+            <a:br/>
+            <a:r>
+              <a:t>  Shows exact surplus amount with custom allocation controls:</a:t>
+            </a:r>
+            <a:br/>
+            <a:r>
+              <a:t>  - Sweep 100% to Emergency Fund</a:t>
+            </a:r>
+            <a:br/>
+            <a:r>
+              <a:t>  - Split between Travel &amp; Tech Goals</a:t>
+            </a:r>
+            <a:br/>
+            <a:r>
+              <a:t>  - Carry forward to next month's allowance</a:t>
+            </a:r>
+            <a:br/>
+            <a:br/>
+            <a:r>
+              <a:t>• Eliminates End-of-Month Leakage:</a:t>
+            </a:r>
+            <a:br/>
+            <a:r>
+              <a:t>  Unallocated money doesn't disappear into casual spending.</a:t>
             </a:r>
           </a:p>
         </p:txBody>
@@ -5647,87 +6063,8 @@
         </p:nvSpPr>
         <p:spPr>
           <a:xfrm>
-            <a:off x="4425696" y="2011680"/>
-            <a:ext cx="3328416" cy="4114800"/>
-          </a:xfrm>
-          <a:prstGeom prst="roundRect">
-            <a:avLst/>
-          </a:prstGeom>
-          <a:solidFill>
-            <a:srgbClr val="1E293B"/>
-          </a:solidFill>
-          <a:ln w="19050">
-            <a:solidFill>
-              <a:srgbClr val="22C55E"/>
-            </a:solidFill>
-          </a:ln>
-        </p:spPr>
-        <p:style>
-          <a:lnRef idx="1">
-            <a:schemeClr val="accent1"/>
-          </a:lnRef>
-          <a:fillRef idx="3">
-            <a:schemeClr val="accent1"/>
-          </a:fillRef>
-          <a:effectRef idx="2">
-            <a:schemeClr val="accent1"/>
-          </a:effectRef>
-          <a:fontRef idx="minor">
-            <a:schemeClr val="lt1"/>
-          </a:fontRef>
-        </p:style>
-        <p:txBody>
-          <a:bodyPr rtlCol="0" anchor="ctr" wrap="square" tIns="274320" lIns="274320" rIns="274320"/>
-          <a:lstStyle/>
-          <a:p>
-            <a:pPr algn="ctr">
-              <a:defRPr sz="1600" b="1">
-                <a:solidFill>
-                  <a:srgbClr val="22C55E"/>
-                </a:solidFill>
-              </a:defRPr>
-            </a:pPr>
-            <a:r>
-              <a:t>Budget vs. Actual</a:t>
-            </a:r>
-          </a:p>
-          <a:p>
-            <a:pPr>
-              <a:defRPr sz="1200">
-                <a:solidFill>
-                  <a:srgbClr val="F8FAFC"/>
-                </a:solidFill>
-              </a:defRPr>
-            </a:pPr>
-            <a:r>
-              <a:t>Real-time limit tracking with visual progress indicators:</a:t>
-            </a:r>
-            <a:br/>
-            <a:br/>
-            <a:r>
-              <a:t>• Green: Safe spending</a:t>
-            </a:r>
-            <a:br/>
-            <a:r>
-              <a:t>• Amber: Near 80% limit warning</a:t>
-            </a:r>
-            <a:br/>
-            <a:r>
-              <a:t>• Red: Overspent category alert</a:t>
-            </a:r>
-          </a:p>
-        </p:txBody>
-      </p:sp>
-      <p:sp>
-        <p:nvSpPr>
-          <p:cNvPr id="9" name="Rounded Rectangle 8"/>
-          <p:cNvSpPr/>
-          <p:nvPr/>
-        </p:nvSpPr>
-        <p:spPr>
-          <a:xfrm>
-            <a:off x="8119872" y="2011680"/>
-            <a:ext cx="3328416" cy="4114800"/>
+            <a:off x="6217920" y="2011680"/>
+            <a:ext cx="5212080" cy="3931920"/>
           </a:xfrm>
           <a:prstGeom prst="roundRect">
             <a:avLst/>
@@ -5760,39 +6097,60 @@
           <a:lstStyle/>
           <a:p>
             <a:pPr algn="ctr">
-              <a:defRPr sz="1600" b="1">
+              <a:defRPr sz="1200" b="1">
                 <a:solidFill>
                   <a:srgbClr val="F59E0B"/>
                 </a:solidFill>
               </a:defRPr>
             </a:pPr>
             <a:r>
-              <a:t>MoM Cash Flow Bar Chart</a:t>
+              <a:t>MULTI-GOAL VAULT &amp; DISCIPLINE</a:t>
             </a:r>
           </a:p>
           <a:p>
             <a:pPr>
-              <a:defRPr sz="1200">
+              <a:defRPr sz="1100">
                 <a:solidFill>
                   <a:srgbClr val="F8FAFC"/>
                 </a:solidFill>
               </a:defRPr>
             </a:pPr>
             <a:r>
-              <a:t>Historical month-over-month bar chart comparing:</a:t>
-            </a:r>
-            <a:br/>
-            <a:br/>
-            <a:r>
-              <a:t>• Total Income vs. Total Expenses</a:t>
-            </a:r>
-            <a:br/>
-            <a:r>
-              <a:t>• Net savings margin and rate</a:t>
-            </a:r>
-            <a:br/>
-            <a:r>
-              <a:t>• Fully interactive across past salary cycles</a:t>
+              <a:t>• Dedicated Multi-Target Goals:</a:t>
+            </a:r>
+            <a:br/>
+            <a:r>
+              <a:t>  Create named vaults with target dates and target amounts:</a:t>
+            </a:r>
+            <a:br/>
+            <a:r>
+              <a:t>  🛡️ Emergency Fund ............. 18,500 / 30,000 EGP (61%)</a:t>
+            </a:r>
+            <a:br/>
+            <a:r>
+              <a:t>  ✈️ Summer Vacation ........... 8,200 / 12,000 EGP (68%)</a:t>
+            </a:r>
+            <a:br/>
+            <a:r>
+              <a:t>  💻 Tech Hardware Upgrade ...... 4,000 / 15,000 EGP (26%)</a:t>
+            </a:r>
+            <a:br/>
+            <a:br/>
+            <a:r>
+              <a:t>• Unallocated Income Synchronization:</a:t>
+            </a:r>
+            <a:br/>
+            <a:r>
+              <a:t>  Income exceeding planned category budgets automatically populates Vault Available Capital.</a:t>
+            </a:r>
+            <a:br/>
+            <a:br/>
+            <a:r>
+              <a:t>• Deposit &amp; Withdrawal History:</a:t>
+            </a:r>
+            <a:br/>
+            <a:r>
+              <a:t>  Full audit log with timestamps and rationale.</a:t>
             </a:r>
           </a:p>
         </p:txBody>
@@ -5926,12 +6284,12 @@
             <a:pPr>
               <a:defRPr sz="1000" b="1">
                 <a:solidFill>
-                  <a:srgbClr val="22C55E"/>
-                </a:solidFill>
-              </a:defRPr>
-            </a:pPr>
-            <a:r>
-              <a:t>PRIVACY &amp; INTELLIGENCE</a:t>
+                  <a:srgbClr val="16A34A"/>
+                </a:solidFill>
+              </a:defRPr>
+            </a:pPr>
+            <a:r>
+              <a:t>GLOBAL ACCESSIBILITY</a:t>
             </a:r>
           </a:p>
         </p:txBody>
@@ -5966,7 +6324,7 @@
               </a:defRPr>
             </a:pPr>
             <a:r>
-              <a:t>Bank-Grade Security &amp; Smart PIN Lifecycle</a:t>
+              <a:t>Native Bilingual &amp; Full Arabic RTL</a:t>
             </a:r>
           </a:p>
         </p:txBody>
@@ -6001,7 +6359,7 @@
               </a:defRPr>
             </a:pPr>
             <a:r>
-              <a:t>Protecting your financial data with zero annoying interruptions.</a:t>
+              <a:t>Complete right-to-left UI mirroring with Eastern Arabic numerals and currency.</a:t>
             </a:r>
           </a:p>
         </p:txBody>
@@ -6016,93 +6374,6 @@
           <a:xfrm>
             <a:off x="731520" y="2011680"/>
             <a:ext cx="5120640" cy="3931920"/>
-          </a:xfrm>
-          <a:prstGeom prst="roundRect">
-            <a:avLst/>
-          </a:prstGeom>
-          <a:solidFill>
-            <a:srgbClr val="1E293B"/>
-          </a:solidFill>
-          <a:ln w="19050">
-            <a:solidFill>
-              <a:srgbClr val="22C55E"/>
-            </a:solidFill>
-          </a:ln>
-        </p:spPr>
-        <p:style>
-          <a:lnRef idx="1">
-            <a:schemeClr val="accent1"/>
-          </a:lnRef>
-          <a:fillRef idx="3">
-            <a:schemeClr val="accent1"/>
-          </a:fillRef>
-          <a:effectRef idx="2">
-            <a:schemeClr val="accent1"/>
-          </a:effectRef>
-          <a:fontRef idx="minor">
-            <a:schemeClr val="lt1"/>
-          </a:fontRef>
-        </p:style>
-        <p:txBody>
-          <a:bodyPr rtlCol="0" anchor="ctr" wrap="square" tIns="274320" lIns="274320" rIns="274320"/>
-          <a:lstStyle/>
-          <a:p>
-            <a:pPr algn="ctr">
-              <a:defRPr sz="1200" b="1">
-                <a:solidFill>
-                  <a:srgbClr val="22C55E"/>
-                </a:solidFill>
-              </a:defRPr>
-            </a:pPr>
-            <a:r>
-              <a:t>SMART 4-DIGIT PIN LOCK</a:t>
-            </a:r>
-          </a:p>
-          <a:p>
-            <a:pPr>
-              <a:defRPr sz="1100">
-                <a:solidFill>
-                  <a:srgbClr val="F8FAFC"/>
-                </a:solidFill>
-              </a:defRPr>
-            </a:pPr>
-            <a:r>
-              <a:t>• Cryptographic SHA-256 Hashing:</a:t>
-            </a:r>
-            <a:br/>
-            <a:r>
-              <a:t>  Your PIN is salted and hashed locally. The raw PIN never touches disk, logs, or network.</a:t>
-            </a:r>
-            <a:br/>
-            <a:br/>
-            <a:r>
-              <a:t>• Smart Lifecycle Awareness:</a:t>
-            </a:r>
-            <a:br/>
-            <a:r>
-              <a:t>  Unlike basic PIN locks, SpendWise understands system states:</a:t>
-            </a:r>
-            <a:br/>
-            <a:r>
-              <a:t>  - Swiping status bar / Wi-Fi toggle (inactive): Session remains unlocked.</a:t>
-            </a:r>
-            <a:br/>
-            <a:r>
-              <a:t>  - Leaving app or locking screen (paused): Immediately locks the session.</a:t>
-            </a:r>
-          </a:p>
-        </p:txBody>
-      </p:sp>
-      <p:sp>
-        <p:nvSpPr>
-          <p:cNvPr id="8" name="Rounded Rectangle 7"/>
-          <p:cNvSpPr/>
-          <p:nvPr/>
-        </p:nvSpPr>
-        <p:spPr>
-          <a:xfrm>
-            <a:off x="6217920" y="2011680"/>
-            <a:ext cx="5212080" cy="3931920"/>
           </a:xfrm>
           <a:prstGeom prst="roundRect">
             <a:avLst/>
@@ -6142,7 +6413,7 @@
               </a:defRPr>
             </a:pPr>
             <a:r>
-              <a:t>RELIABLE NOTIFICATIONS &amp; CSV EXPORT</a:t>
+              <a:t>FIRST-CLASS RTL MIRRORING</a:t>
             </a:r>
           </a:p>
           <a:p>
@@ -6154,24 +6425,129 @@
               </a:defRPr>
             </a:pPr>
             <a:r>
-              <a:t>• Daily Evening Reminder:</a:t>
-            </a:r>
-            <a:br/>
-            <a:r>
-              <a:t>  Scheduled local alarm (default 9:00 PM) prompting you to record expenses.</a:t>
-            </a:r>
-            <a:br/>
-            <a:r>
-              <a:t>  Uses flutter_timezone to detect exact IANA timezones (e.g. Africa/Cairo) and Android exact alarms.</a:t>
-            </a:r>
-            <a:br/>
-            <a:br/>
-            <a:r>
-              <a:t>• 1-Tap CSV Data Portability:</a:t>
-            </a:r>
-            <a:br/>
-            <a:r>
-              <a:t>  Export all transactions or current cycle summary directly to Excel or Google Sheets. 100% data ownership.</a:t>
+              <a:t>• Complete Layout Mirroring:</a:t>
+            </a:r>
+            <a:br/>
+            <a:r>
+              <a:t>  Every UI component respects Directionality:</a:t>
+            </a:r>
+            <a:br/>
+            <a:r>
+              <a:t>  - Floating action buttons reposition seamlessly.</a:t>
+            </a:r>
+            <a:br/>
+            <a:r>
+              <a:t>  - Navigation drawer and back buttons flip correctly.</a:t>
+            </a:r>
+            <a:br/>
+            <a:r>
+              <a:t>  - Progress bars, charts, and cards align naturally.</a:t>
+            </a:r>
+            <a:br/>
+            <a:br/>
+            <a:r>
+              <a:t>• 1-Tap Instant Language Switch:</a:t>
+            </a:r>
+            <a:br/>
+            <a:r>
+              <a:t>  Toggle between English and Arabic instantly in Settings without requiring an app restart.</a:t>
+            </a:r>
+            <a:br/>
+            <a:br/>
+            <a:r>
+              <a:t>• Culturally Fluent Translation:</a:t>
+            </a:r>
+            <a:br/>
+            <a:r>
+              <a:t>  Professional terminology crafted specifically for personal finance in the Arab world.</a:t>
+            </a:r>
+          </a:p>
+        </p:txBody>
+      </p:sp>
+      <p:sp>
+        <p:nvSpPr>
+          <p:cNvPr id="8" name="Rounded Rectangle 7"/>
+          <p:cNvSpPr/>
+          <p:nvPr/>
+        </p:nvSpPr>
+        <p:spPr>
+          <a:xfrm>
+            <a:off x="6217920" y="2011680"/>
+            <a:ext cx="5212080" cy="3931920"/>
+          </a:xfrm>
+          <a:prstGeom prst="roundRect">
+            <a:avLst/>
+          </a:prstGeom>
+          <a:solidFill>
+            <a:srgbClr val="1E293B"/>
+          </a:solidFill>
+          <a:ln w="19050">
+            <a:solidFill>
+              <a:srgbClr val="16A34A"/>
+            </a:solidFill>
+          </a:ln>
+        </p:spPr>
+        <p:style>
+          <a:lnRef idx="1">
+            <a:schemeClr val="accent1"/>
+          </a:lnRef>
+          <a:fillRef idx="3">
+            <a:schemeClr val="accent1"/>
+          </a:fillRef>
+          <a:effectRef idx="2">
+            <a:schemeClr val="accent1"/>
+          </a:effectRef>
+          <a:fontRef idx="minor">
+            <a:schemeClr val="lt1"/>
+          </a:fontRef>
+        </p:style>
+        <p:txBody>
+          <a:bodyPr rtlCol="0" anchor="ctr" wrap="square" tIns="274320" lIns="274320" rIns="274320"/>
+          <a:lstStyle/>
+          <a:p>
+            <a:pPr algn="ctr">
+              <a:defRPr sz="1200" b="1">
+                <a:solidFill>
+                  <a:srgbClr val="16A34A"/>
+                </a:solidFill>
+              </a:defRPr>
+            </a:pPr>
+            <a:r>
+              <a:t>EASTERN ARABIC NUMERALS &amp; LOCAL CURRENCY</a:t>
+            </a:r>
+          </a:p>
+          <a:p>
+            <a:pPr>
+              <a:defRPr sz="1100">
+                <a:solidFill>
+                  <a:srgbClr val="F8FAFC"/>
+                </a:solidFill>
+              </a:defRPr>
+            </a:pPr>
+            <a:r>
+              <a:t>• Eastern Arabic Digits (٠ ١ ٢ ٣ ٤ ٥ ٦ ٧ ٨ ٩):</a:t>
+            </a:r>
+            <a:br/>
+            <a:r>
+              <a:t>  Optional toggle to render all numeric values, dates, and amounts in traditional Eastern Arabic numerals.</a:t>
+            </a:r>
+            <a:br/>
+            <a:br/>
+            <a:r>
+              <a:t>• Localized Currency Representation:</a:t>
+            </a:r>
+            <a:br/>
+            <a:r>
+              <a:t>  Seamless switching between 'EGP' and 'ج.م' (Egyptian Pound), USD, EUR, and more.</a:t>
+            </a:r>
+            <a:br/>
+            <a:br/>
+            <a:r>
+              <a:t>• Strict Bi-Directional Typography:</a:t>
+            </a:r>
+            <a:br/>
+            <a:r>
+              <a:t>  Text frames and number formatting maintain perfect baseline alignment across bilingual strings.</a:t>
             </a:r>
           </a:p>
         </p:txBody>
@@ -6305,12 +6681,12 @@
             <a:pPr>
               <a:defRPr sz="1000" b="1">
                 <a:solidFill>
-                  <a:srgbClr val="22C55E"/>
-                </a:solidFill>
-              </a:defRPr>
-            </a:pPr>
-            <a:r>
-              <a:t>ENGINEERING EXCELLENCE</a:t>
+                  <a:srgbClr val="16A34A"/>
+                </a:solidFill>
+              </a:defRPr>
+            </a:pPr>
+            <a:r>
+              <a:t>BANK-GRADE PRIVACY</a:t>
             </a:r>
           </a:p>
         </p:txBody>
@@ -6345,7 +6721,7 @@
               </a:defRPr>
             </a:pPr>
             <a:r>
-              <a:t>Modern Architecture &amp; Automated Quality</a:t>
+              <a:t>Bank-Grade Security &amp; Data Portability</a:t>
             </a:r>
           </a:p>
         </p:txBody>
@@ -6380,7 +6756,7 @@
               </a:defRPr>
             </a:pPr>
             <a:r>
-              <a:t>Built on clean architecture with comprehensive automated test coverage.</a:t>
+              <a:t>Protecting your financial records with zero third-party exposure.</a:t>
             </a:r>
           </a:p>
         </p:txBody>
@@ -6402,9 +6778,9 @@
           <a:solidFill>
             <a:srgbClr val="1E293B"/>
           </a:solidFill>
-          <a:ln>
+          <a:ln w="19050">
             <a:solidFill>
-              <a:srgbClr val="334155"/>
+              <a:srgbClr val="16A34A"/>
             </a:solidFill>
           </a:ln>
         </p:spPr>
@@ -6429,12 +6805,12 @@
             <a:pPr algn="ctr">
               <a:defRPr sz="1200" b="1">
                 <a:solidFill>
-                  <a:srgbClr val="6366F1"/>
-                </a:solidFill>
-              </a:defRPr>
-            </a:pPr>
-            <a:r>
-              <a:t>TECHNICAL STACK</a:t>
+                  <a:srgbClr val="16A34A"/>
+                </a:solidFill>
+              </a:defRPr>
+            </a:pPr>
+            <a:r>
+              <a:t>CRYPTOGRAPHIC PIN &amp; BIOMETRICS</a:t>
             </a:r>
           </a:p>
           <a:p>
@@ -6446,31 +6822,33 @@
               </a:defRPr>
             </a:pPr>
             <a:r>
-              <a:t>• Framework: Flutter 3.x / Dart 3.x</a:t>
-            </a:r>
-            <a:br/>
-            <a:r>
-              <a:t>• State: Riverpod 2 (Notifier / Unidirectional flow)</a:t>
-            </a:r>
-            <a:br/>
-            <a:r>
-              <a:t>• Database: Drift (Type-safe SQLite ORM)</a:t>
-            </a:r>
-            <a:br/>
-            <a:r>
-              <a:t>• Math: Integer Minor Units (Zero floating-point errors)</a:t>
-            </a:r>
-            <a:br/>
-            <a:r>
-              <a:t>• Notifications: flutter_local_notifications + flutter_timezone</a:t>
-            </a:r>
-            <a:br/>
-            <a:r>
-              <a:t>• Theming: ThemeContextExt (High contrast Dark/Light tokens)</a:t>
-            </a:r>
-            <a:br/>
-            <a:r>
-              <a:t>• APK Size: Strictly under 80MB</a:t>
+              <a:t>• Salted SHA-256 Hashing:</a:t>
+            </a:r>
+            <a:br/>
+            <a:r>
+              <a:t>  Your PIN is cryptographically hashed with local salt. Raw PINs never touch disk, logs, or network.</a:t>
+            </a:r>
+            <a:br/>
+            <a:br/>
+            <a:r>
+              <a:t>• Biometric Authentication:</a:t>
+            </a:r>
+            <a:br/>
+            <a:r>
+              <a:t>  Fast fingerprint and face unlock via local_auth.</a:t>
+            </a:r>
+            <a:br/>
+            <a:br/>
+            <a:r>
+              <a:t>• Smart Lifecycle Awareness:</a:t>
+            </a:r>
+            <a:br/>
+            <a:r>
+              <a:t>  - Swiping status bar / Wi-Fi toggle (inactive): Session remains active.</a:t>
+            </a:r>
+            <a:br/>
+            <a:r>
+              <a:t>  - App sent to background or phone locked (paused): Immediately re-locks session.</a:t>
             </a:r>
           </a:p>
         </p:txBody>
@@ -6494,7 +6872,7 @@
           </a:solidFill>
           <a:ln w="19050">
             <a:solidFill>
-              <a:srgbClr val="22C55E"/>
+              <a:srgbClr val="6366F1"/>
             </a:solidFill>
           </a:ln>
         </p:spPr>
@@ -6519,12 +6897,12 @@
             <a:pPr algn="ctr">
               <a:defRPr sz="1200" b="1">
                 <a:solidFill>
-                  <a:srgbClr val="22C55E"/>
-                </a:solidFill>
-              </a:defRPr>
-            </a:pPr>
-            <a:r>
-              <a:t>AUTOMATED TEST SUITE: 90 / 90 PASSING</a:t>
+                  <a:srgbClr val="6366F1"/>
+                </a:solidFill>
+              </a:defRPr>
+            </a:pPr>
+            <a:r>
+              <a:t>OFFLINE BACKUP &amp; CSV PORTABILITY</a:t>
             </a:r>
           </a:p>
           <a:p>
@@ -6536,38 +6914,29 @@
               </a:defRPr>
             </a:pPr>
             <a:r>
-              <a:t>• Money Value Object Tests:</a:t>
-            </a:r>
-            <a:br/>
-            <a:r>
-              <a:t>  Exact addition, subtraction, division, and rounding.</a:t>
-            </a:r>
-            <a:br/>
-            <a:br/>
-            <a:r>
-              <a:t>• Budget Cycle Calculator Tests:</a:t>
-            </a:r>
-            <a:br/>
-            <a:r>
-              <a:t>  25th-to-24th salary boundary transitions &amp; leap years.</a:t>
-            </a:r>
-            <a:br/>
-            <a:br/>
-            <a:r>
-              <a:t>• Database Integrity Tests:</a:t>
-            </a:r>
-            <a:br/>
-            <a:r>
-              <a:t>  Foreign keys, cascade renaming, and safe deletion.</a:t>
-            </a:r>
-            <a:br/>
-            <a:br/>
-            <a:r>
-              <a:t>• Security &amp; Lifecycle Widget Tests:</a:t>
-            </a:r>
-            <a:br/>
-            <a:r>
-              <a:t>  Validating PIN hashing, status bar swipe, and pause lock.</a:t>
+              <a:t>• 100% Offline JSON Backup &amp; Restore:</a:t>
+            </a:r>
+            <a:br/>
+            <a:r>
+              <a:t>  Export full encrypted JSON database backups to transfer to new devices or store securely offline.</a:t>
+            </a:r>
+            <a:br/>
+            <a:br/>
+            <a:r>
+              <a:t>• 1-Tap CSV Data Portability:</a:t>
+            </a:r>
+            <a:br/>
+            <a:r>
+              <a:t>  Export all transactions or filtered cycle records directly to Excel or Google Sheets.</a:t>
+            </a:r>
+            <a:br/>
+            <a:br/>
+            <a:r>
+              <a:t>• Zero Cloud Exposure:</a:t>
+            </a:r>
+            <a:br/>
+            <a:r>
+              <a:t>  No servers, no tracking SDKs, no external ads. Your financial life belongs solely to you.</a:t>
             </a:r>
           </a:p>
         </p:txBody>
@@ -6701,12 +7070,12 @@
             <a:pPr>
               <a:defRPr sz="1000" b="1">
                 <a:solidFill>
-                  <a:srgbClr val="22C55E"/>
-                </a:solidFill>
-              </a:defRPr>
-            </a:pPr>
-            <a:r>
-              <a:t>SUMMARY &amp; NEXT STEPS</a:t>
+                  <a:srgbClr val="16A34A"/>
+                </a:solidFill>
+              </a:defRPr>
+            </a:pPr>
+            <a:r>
+              <a:t>ENGINEERING EXCELLENCE</a:t>
             </a:r>
           </a:p>
         </p:txBody>
@@ -6741,7 +7110,7 @@
               </a:defRPr>
             </a:pPr>
             <a:r>
-              <a:t>SpendWise: The Future of Personal Finance</a:t>
+              <a:t>Modern Architecture &amp; Automated Quality</a:t>
             </a:r>
           </a:p>
         </p:txBody>
@@ -6776,7 +7145,7 @@
               </a:defRPr>
             </a:pPr>
             <a:r>
-              <a:t>Empowering users with effortless financial clarity every single day.</a:t>
+              <a:t>Built on clean architecture with 100% passing automated test coverage.</a:t>
             </a:r>
           </a:p>
         </p:txBody>
@@ -6791,6 +7160,100 @@
           <a:xfrm>
             <a:off x="731520" y="2011680"/>
             <a:ext cx="5120640" cy="3931920"/>
+          </a:xfrm>
+          <a:prstGeom prst="roundRect">
+            <a:avLst/>
+          </a:prstGeom>
+          <a:solidFill>
+            <a:srgbClr val="1E293B"/>
+          </a:solidFill>
+          <a:ln>
+            <a:solidFill>
+              <a:srgbClr val="334155"/>
+            </a:solidFill>
+          </a:ln>
+        </p:spPr>
+        <p:style>
+          <a:lnRef idx="1">
+            <a:schemeClr val="accent1"/>
+          </a:lnRef>
+          <a:fillRef idx="3">
+            <a:schemeClr val="accent1"/>
+          </a:fillRef>
+          <a:effectRef idx="2">
+            <a:schemeClr val="accent1"/>
+          </a:effectRef>
+          <a:fontRef idx="minor">
+            <a:schemeClr val="lt1"/>
+          </a:fontRef>
+        </p:style>
+        <p:txBody>
+          <a:bodyPr rtlCol="0" anchor="ctr" wrap="square" tIns="274320" lIns="274320" rIns="274320"/>
+          <a:lstStyle/>
+          <a:p>
+            <a:pPr algn="ctr">
+              <a:defRPr sz="1200" b="1">
+                <a:solidFill>
+                  <a:srgbClr val="6366F1"/>
+                </a:solidFill>
+              </a:defRPr>
+            </a:pPr>
+            <a:r>
+              <a:t>TECHNICAL STACK</a:t>
+            </a:r>
+          </a:p>
+          <a:p>
+            <a:pPr>
+              <a:defRPr sz="1100">
+                <a:solidFill>
+                  <a:srgbClr val="F8FAFC"/>
+                </a:solidFill>
+              </a:defRPr>
+            </a:pPr>
+            <a:r>
+              <a:t>• Framework: Flutter 3.x / Dart 3.x</a:t>
+            </a:r>
+            <a:br/>
+            <a:r>
+              <a:t>• State Management: Riverpod 2 (Notifier / Unidirectional)</a:t>
+            </a:r>
+            <a:br/>
+            <a:r>
+              <a:t>• Database: Drift (Type-safe SQLite ORM)</a:t>
+            </a:r>
+            <a:br/>
+            <a:r>
+              <a:t>• Math: Integer Minor Units (Zero floating-point errors)</a:t>
+            </a:r>
+            <a:br/>
+            <a:r>
+              <a:t>• Notifications: flutter_local_notifications + flutter_timezone</a:t>
+            </a:r>
+            <a:br/>
+            <a:r>
+              <a:t>• Theming: ThemeContextExt (High contrast Dark/Light tokens)</a:t>
+            </a:r>
+            <a:br/>
+            <a:r>
+              <a:t>• Binary Size: 22.7 MB (ARM64) / 62.1 MB (Universal)</a:t>
+            </a:r>
+            <a:br/>
+            <a:r>
+              <a:t>• Code Quality: 0 analyzer issues, 0 lint warnings</a:t>
+            </a:r>
+          </a:p>
+        </p:txBody>
+      </p:sp>
+      <p:sp>
+        <p:nvSpPr>
+          <p:cNvPr id="8" name="Rounded Rectangle 7"/>
+          <p:cNvSpPr/>
+          <p:nvPr/>
+        </p:nvSpPr>
+        <p:spPr>
+          <a:xfrm>
+            <a:off x="6217920" y="2011680"/>
+            <a:ext cx="5212080" cy="3931920"/>
           </a:xfrm>
           <a:prstGeom prst="roundRect">
             <a:avLst/>
@@ -6800,7 +7263,7 @@
           </a:solidFill>
           <a:ln w="19050">
             <a:solidFill>
-              <a:srgbClr val="22C55E"/>
+              <a:srgbClr val="16A34A"/>
             </a:solidFill>
           </a:ln>
         </p:spPr>
@@ -6825,12 +7288,12 @@
             <a:pPr algn="ctr">
               <a:defRPr sz="1200" b="1">
                 <a:solidFill>
-                  <a:srgbClr val="22C55E"/>
-                </a:solidFill>
-              </a:defRPr>
-            </a:pPr>
-            <a:r>
-              <a:t>WHAT SETS SPENDWISE APART</a:t>
+                  <a:srgbClr val="16A34A"/>
+                </a:solidFill>
+              </a:defRPr>
+            </a:pPr>
+            <a:r>
+              <a:t>AUTOMATED TEST SUITE: 162 / 162 PASSING</a:t>
             </a:r>
           </a:p>
           <a:p>
@@ -6842,120 +7305,47 @@
               </a:defRPr>
             </a:pPr>
             <a:r>
-              <a:t>• Built for real paydays: 25th-to-24th salary cycle.</a:t>
-            </a:r>
-            <a:br/>
-            <a:r>
-              <a:t>• Sub-second entry: 1-Tap quick presets with Undo.</a:t>
-            </a:r>
-            <a:br/>
-            <a:r>
-              <a:t>• Instant daily feedback: Today's spending &amp; safe pace.</a:t>
-            </a:r>
-            <a:br/>
-            <a:r>
-              <a:t>• 100% privacy: Zero tracking, local SQLite storage.</a:t>
-            </a:r>
-            <a:br/>
-            <a:r>
-              <a:t>• Light &amp; fast: Under 80MB, battery-efficient.</a:t>
-            </a:r>
-          </a:p>
-        </p:txBody>
-      </p:sp>
-      <p:sp>
-        <p:nvSpPr>
-          <p:cNvPr id="8" name="Rounded Rectangle 7"/>
-          <p:cNvSpPr/>
-          <p:nvPr/>
-        </p:nvSpPr>
-        <p:spPr>
-          <a:xfrm>
-            <a:off x="6217920" y="2011680"/>
-            <a:ext cx="5212080" cy="3931920"/>
-          </a:xfrm>
-          <a:prstGeom prst="roundRect">
-            <a:avLst/>
-          </a:prstGeom>
-          <a:solidFill>
-            <a:srgbClr val="1E293B"/>
-          </a:solidFill>
-          <a:ln w="19050">
-            <a:solidFill>
-              <a:srgbClr val="6366F1"/>
-            </a:solidFill>
-          </a:ln>
-        </p:spPr>
-        <p:style>
-          <a:lnRef idx="1">
-            <a:schemeClr val="accent1"/>
-          </a:lnRef>
-          <a:fillRef idx="3">
-            <a:schemeClr val="accent1"/>
-          </a:fillRef>
-          <a:effectRef idx="2">
-            <a:schemeClr val="accent1"/>
-          </a:effectRef>
-          <a:fontRef idx="minor">
-            <a:schemeClr val="lt1"/>
-          </a:fontRef>
-        </p:style>
-        <p:txBody>
-          <a:bodyPr rtlCol="0" anchor="ctr" wrap="square" tIns="274320" lIns="274320" rIns="274320"/>
-          <a:lstStyle/>
-          <a:p>
-            <a:pPr algn="ctr">
-              <a:defRPr sz="1200" b="1">
-                <a:solidFill>
-                  <a:srgbClr val="6366F1"/>
-                </a:solidFill>
-              </a:defRPr>
-            </a:pPr>
-            <a:r>
-              <a:t>UPCOMING HORIZONS</a:t>
-            </a:r>
-          </a:p>
-          <a:p>
-            <a:pPr>
-              <a:defRPr sz="1100">
-                <a:solidFill>
-                  <a:srgbClr val="F8FAFC"/>
-                </a:solidFill>
-              </a:defRPr>
-            </a:pPr>
-            <a:r>
-              <a:t>• Interactive Category Donut Chart:</a:t>
-            </a:r>
-            <a:br/>
-            <a:r>
-              <a:t>  Tap-to-highlight category shares in Reports.</a:t>
-            </a:r>
-            <a:br/>
-            <a:br/>
-            <a:r>
-              <a:t>• 1-Tap Duplicate Entry:</a:t>
-            </a:r>
-            <a:br/>
-            <a:r>
-              <a:t>  Clone recurring transactions directly from ledger.</a:t>
-            </a:r>
-            <a:br/>
-            <a:br/>
-            <a:r>
-              <a:t>• Offline Backup &amp; Restore:</a:t>
-            </a:r>
-            <a:br/>
-            <a:r>
-              <a:t>  Export and import complete JSON backups for new phones.</a:t>
-            </a:r>
-            <a:br/>
-            <a:br/>
-            <a:r>
-              <a:t>• Subtle Haptic Feedback:</a:t>
-            </a:r>
-            <a:br/>
-            <a:r>
-              <a:t>  Gentle tactile vibration on preset and PIN taps.</a:t>
+              <a:t>• Money Value Object Tests:</a:t>
+            </a:r>
+            <a:br/>
+            <a:r>
+              <a:t>  Exact addition, subtraction, division, and rounding.</a:t>
+            </a:r>
+            <a:br/>
+            <a:br/>
+            <a:r>
+              <a:t>• Budget Cycle Calculator Tests:</a:t>
+            </a:r>
+            <a:br/>
+            <a:r>
+              <a:t>  25th-to-24th salary boundary transitions &amp; leap years.</a:t>
+            </a:r>
+            <a:br/>
+            <a:br/>
+            <a:r>
+              <a:t>• Savings Vault &amp; Sweeper Tests:</a:t>
+            </a:r>
+            <a:br/>
+            <a:r>
+              <a:t>  Surplus sweeping, multi-goal progress, unallocated sync.</a:t>
+            </a:r>
+            <a:br/>
+            <a:br/>
+            <a:r>
+              <a:t>• Database Integrity &amp; Migration Tests:</a:t>
+            </a:r>
+            <a:br/>
+            <a:r>
+              <a:t>  Foreign keys, cascade renaming, safe deletion.</a:t>
+            </a:r>
+            <a:br/>
+            <a:br/>
+            <a:r>
+              <a:t>• Security &amp; Lifecycle Widget Tests:</a:t>
+            </a:r>
+            <a:br/>
+            <a:r>
+              <a:t>  PIN hashing, inactive vs paused status, biometrics.</a:t>
             </a:r>
           </a:p>
         </p:txBody>

</xml_diff>